<commit_message>
Update to Zelda EHTAM
</commit_message>
<xml_diff>
--- a/TDHC/Resources/TDHC_IA_MCP_TDHC.pptx
+++ b/TDHC/Resources/TDHC_IA_MCP_TDHC.pptx
@@ -2916,7 +2916,18 @@
                 <a:ea typeface="Calibri" pitchFamily="34" charset="-122"/>
                 <a:cs typeface="Calibri" pitchFamily="34" charset="-120"/>
               </a:rPr>
-              <a:t>&gt; “Fais-moi une synthèse médicale du patient John DOE”</a:t>
+              <a:t>&gt; “Fais-moi une synthèse médicale du </a:t>
+            </a:r>
+            <a:r>
+              <a:rPr lang="en-US" sz="1400">
+                <a:solidFill>
+                  <a:srgbClr val="0F172A"/>
+                </a:solidFill>
+                <a:latin typeface="Consolas" panose="020B0609020204030204" pitchFamily="49" charset="0"/>
+                <a:ea typeface="Calibri" pitchFamily="34" charset="-122"/>
+                <a:cs typeface="Calibri" pitchFamily="34" charset="-120"/>
+              </a:rPr>
+              <a:t>patient Zelda EHTAM”</a:t>
             </a:r>
             <a:endParaRPr lang="en-US" sz="1400" dirty="0">
               <a:latin typeface="Consolas" panose="020B0609020204030204" pitchFamily="49" charset="0"/>
@@ -12525,6 +12536,23 @@
 </file>
 
 <file path=customXml/item1.xml><?xml version="1.0" encoding="utf-8"?>
+<p:properties xmlns:p="http://schemas.microsoft.com/office/2006/metadata/properties" xmlns:xsi="http://www.w3.org/2001/XMLSchema-instance" xmlns:pc="http://schemas.microsoft.com/office/infopath/2007/PartnerControls">
+  <documentManagement>
+    <_activity xmlns="2e18fd24-1e72-4026-afc1-ad0e4ee2cd8f" xsi:nil="true"/>
+  </documentManagement>
+</p:properties>
+</file>
+
+<file path=customXml/item2.xml><?xml version="1.0" encoding="utf-8"?>
+<?mso-contentType ?>
+<FormTemplates xmlns="http://schemas.microsoft.com/sharepoint/v3/contenttype/forms">
+  <Display>DocumentLibraryForm</Display>
+  <Edit>DocumentLibraryForm</Edit>
+  <New>DocumentLibraryForm</New>
+</FormTemplates>
+</file>
+
+<file path=customXml/item3.xml><?xml version="1.0" encoding="utf-8"?>
 <ct:contentTypeSchema xmlns:ct="http://schemas.microsoft.com/office/2006/metadata/contentType" xmlns:ma="http://schemas.microsoft.com/office/2006/metadata/properties/metaAttributes" ct:_="" ma:_="" ma:contentTypeName="Document" ma:contentTypeID="0x01010092776364523B304ABC7CD1287CD641EF" ma:contentTypeVersion="16" ma:contentTypeDescription="Create a new document." ma:contentTypeScope="" ma:versionID="050895b2417a16e1724be928bca4df2b">
   <xsd:schema xmlns:xsd="http://www.w3.org/2001/XMLSchema" xmlns:xs="http://www.w3.org/2001/XMLSchema" xmlns:p="http://schemas.microsoft.com/office/2006/metadata/properties" xmlns:ns3="4c9a34c4-a9d6-4e6c-bef9-30326f0b5268" xmlns:ns4="2e18fd24-1e72-4026-afc1-ad0e4ee2cd8f" targetNamespace="http://schemas.microsoft.com/office/2006/metadata/properties" ma:root="true" ma:fieldsID="12160486c5d71f109b62abadcb75c07a" ns3:_="" ns4:_="">
     <xsd:import namespace="4c9a34c4-a9d6-4e6c-bef9-30326f0b5268"/>
@@ -12763,24 +12791,32 @@
 </ct:contentTypeSchema>
 </file>
 
-<file path=customXml/item2.xml><?xml version="1.0" encoding="utf-8"?>
-<?mso-contentType ?>
-<FormTemplates xmlns="http://schemas.microsoft.com/sharepoint/v3/contenttype/forms">
-  <Display>DocumentLibraryForm</Display>
-  <Edit>DocumentLibraryForm</Edit>
-  <New>DocumentLibraryForm</New>
-</FormTemplates>
+<file path=customXml/itemProps1.xml><?xml version="1.0" encoding="utf-8"?>
+<ds:datastoreItem xmlns:ds="http://schemas.openxmlformats.org/officeDocument/2006/customXml" ds:itemID="{9EB8E7CF-9C39-4E12-98C2-FCE8FA8F8B22}">
+  <ds:schemaRefs>
+    <ds:schemaRef ds:uri="4c9a34c4-a9d6-4e6c-bef9-30326f0b5268"/>
+    <ds:schemaRef ds:uri="http://schemas.microsoft.com/office/2006/metadata/properties"/>
+    <ds:schemaRef ds:uri="http://purl.org/dc/terms/"/>
+    <ds:schemaRef ds:uri="http://purl.org/dc/elements/1.1/"/>
+    <ds:schemaRef ds:uri="http://purl.org/dc/dcmitype/"/>
+    <ds:schemaRef ds:uri="http://schemas.microsoft.com/office/2006/documentManagement/types"/>
+    <ds:schemaRef ds:uri="2e18fd24-1e72-4026-afc1-ad0e4ee2cd8f"/>
+    <ds:schemaRef ds:uri="http://schemas.openxmlformats.org/package/2006/metadata/core-properties"/>
+    <ds:schemaRef ds:uri="http://schemas.microsoft.com/office/infopath/2007/PartnerControls"/>
+    <ds:schemaRef ds:uri="http://www.w3.org/XML/1998/namespace"/>
+  </ds:schemaRefs>
+</ds:datastoreItem>
 </file>
 
-<file path=customXml/item3.xml><?xml version="1.0" encoding="utf-8"?>
-<p:properties xmlns:p="http://schemas.microsoft.com/office/2006/metadata/properties" xmlns:xsi="http://www.w3.org/2001/XMLSchema-instance" xmlns:pc="http://schemas.microsoft.com/office/infopath/2007/PartnerControls">
-  <documentManagement>
-    <_activity xmlns="2e18fd24-1e72-4026-afc1-ad0e4ee2cd8f" xsi:nil="true"/>
-  </documentManagement>
-</p:properties>
+<file path=customXml/itemProps2.xml><?xml version="1.0" encoding="utf-8"?>
+<ds:datastoreItem xmlns:ds="http://schemas.openxmlformats.org/officeDocument/2006/customXml" ds:itemID="{2C867A6B-7373-4DAC-A865-27CA1836C0CF}">
+  <ds:schemaRefs>
+    <ds:schemaRef ds:uri="http://schemas.microsoft.com/sharepoint/v3/contenttype/forms"/>
+  </ds:schemaRefs>
+</ds:datastoreItem>
 </file>
 
-<file path=customXml/itemProps1.xml><?xml version="1.0" encoding="utf-8"?>
+<file path=customXml/itemProps3.xml><?xml version="1.0" encoding="utf-8"?>
 <ds:datastoreItem xmlns:ds="http://schemas.openxmlformats.org/officeDocument/2006/customXml" ds:itemID="{5DAE53FC-7667-41C7-BC23-BF46ADA41028}">
   <ds:schemaRefs>
     <ds:schemaRef ds:uri="http://schemas.microsoft.com/office/2006/metadata/contentType"/>
@@ -12797,29 +12833,4 @@
     <ds:schemaRef ds:uri="http://schemas.microsoft.com/internal/obd"/>
   </ds:schemaRefs>
 </ds:datastoreItem>
-</file>
-
-<file path=customXml/itemProps2.xml><?xml version="1.0" encoding="utf-8"?>
-<ds:datastoreItem xmlns:ds="http://schemas.openxmlformats.org/officeDocument/2006/customXml" ds:itemID="{2C867A6B-7373-4DAC-A865-27CA1836C0CF}">
-  <ds:schemaRefs>
-    <ds:schemaRef ds:uri="http://schemas.microsoft.com/sharepoint/v3/contenttype/forms"/>
-  </ds:schemaRefs>
-</ds:datastoreItem>
-</file>
-
-<file path=customXml/itemProps3.xml><?xml version="1.0" encoding="utf-8"?>
-<ds:datastoreItem xmlns:ds="http://schemas.openxmlformats.org/officeDocument/2006/customXml" ds:itemID="{9EB8E7CF-9C39-4E12-98C2-FCE8FA8F8B22}">
-  <ds:schemaRefs>
-    <ds:schemaRef ds:uri="4c9a34c4-a9d6-4e6c-bef9-30326f0b5268"/>
-    <ds:schemaRef ds:uri="http://schemas.microsoft.com/office/2006/metadata/properties"/>
-    <ds:schemaRef ds:uri="http://purl.org/dc/terms/"/>
-    <ds:schemaRef ds:uri="http://purl.org/dc/elements/1.1/"/>
-    <ds:schemaRef ds:uri="http://purl.org/dc/dcmitype/"/>
-    <ds:schemaRef ds:uri="http://schemas.microsoft.com/office/2006/documentManagement/types"/>
-    <ds:schemaRef ds:uri="2e18fd24-1e72-4026-afc1-ad0e4ee2cd8f"/>
-    <ds:schemaRef ds:uri="http://schemas.openxmlformats.org/package/2006/metadata/core-properties"/>
-    <ds:schemaRef ds:uri="http://schemas.microsoft.com/office/infopath/2007/PartnerControls"/>
-    <ds:schemaRef ds:uri="http://www.w3.org/XML/1998/namespace"/>
-  </ds:schemaRefs>
-</ds:datastoreItem>
 </file>
</xml_diff>